<commit_message>
Added Q & A slide
</commit_message>
<xml_diff>
--- a/09_Post_Analysis/09_Post-analysis.pptx
+++ b/09_Post_Analysis/09_Post-analysis.pptx
@@ -5,16 +5,17 @@
     <p:sldMasterId id="2147483648" r:id="rId1"/>
   </p:sldMasterIdLst>
   <p:notesMasterIdLst>
-    <p:notesMasterId r:id="rId6"/>
+    <p:notesMasterId r:id="rId7"/>
   </p:notesMasterIdLst>
   <p:handoutMasterIdLst>
-    <p:handoutMasterId r:id="rId7"/>
+    <p:handoutMasterId r:id="rId8"/>
   </p:handoutMasterIdLst>
   <p:sldIdLst>
     <p:sldId id="281" r:id="rId2"/>
     <p:sldId id="297" r:id="rId3"/>
-    <p:sldId id="298" r:id="rId4"/>
-    <p:sldId id="266" r:id="rId5"/>
+    <p:sldId id="299" r:id="rId4"/>
+    <p:sldId id="298" r:id="rId5"/>
+    <p:sldId id="266" r:id="rId6"/>
   </p:sldIdLst>
   <p:sldSz cx="12192000" cy="6858000"/>
   <p:notesSz cx="9144000" cy="6858000"/>
@@ -281,7 +282,7 @@
           <a:p>
             <a:fld id="{B0DE400B-5F95-4EE3-9D17-5032615B1C24}" type="datetimeFigureOut">
               <a:rPr lang="hu-HU" smtClean="0"/>
-              <a:t>2026. 02. 26.</a:t>
+              <a:t>2026. 02. 27.</a:t>
             </a:fld>
             <a:endParaRPr lang="hu-HU"/>
           </a:p>
@@ -381,7 +382,7 @@
           <a:p>
             <a:fld id="{A4BC41BF-2966-492C-BF11-EDF0CF116384}" type="datetimeFigureOut">
               <a:rPr lang="hu-HU" smtClean="0"/>
-              <a:t>2026. 02. 26.</a:t>
+              <a:t>2026. 02. 27.</a:t>
             </a:fld>
             <a:endParaRPr lang="hu-HU"/>
           </a:p>
@@ -5061,6 +5062,1055 @@
         <p:cNvPr id="1" name="">
           <a:extLst>
             <a:ext uri="{FF2B5EF4-FFF2-40B4-BE49-F238E27FC236}">
+              <a16:creationId xmlns:a16="http://schemas.microsoft.com/office/drawing/2014/main" id="{7BAB0D0D-B5B2-FB35-EC40-3FAC9ABE7702}"/>
+            </a:ext>
+          </a:extLst>
+        </p:cNvPr>
+        <p:cNvGrpSpPr/>
+        <p:nvPr/>
+      </p:nvGrpSpPr>
+      <p:grpSpPr>
+        <a:xfrm>
+          <a:off x="0" y="0"/>
+          <a:ext cx="0" cy="0"/>
+          <a:chOff x="0" y="0"/>
+          <a:chExt cx="0" cy="0"/>
+        </a:xfrm>
+      </p:grpSpPr>
+      <p:sp>
+        <p:nvSpPr>
+          <p:cNvPr id="4" name="Marcador de Posição do Número do Diapositivo 3">
+            <a:extLst>
+              <a:ext uri="{FF2B5EF4-FFF2-40B4-BE49-F238E27FC236}">
+                <a16:creationId xmlns:a16="http://schemas.microsoft.com/office/drawing/2014/main" id="{0E9FAE5E-5899-641E-BD25-73E417016F07}"/>
+              </a:ext>
+            </a:extLst>
+          </p:cNvPr>
+          <p:cNvSpPr>
+            <a:spLocks noGrp="1"/>
+          </p:cNvSpPr>
+          <p:nvPr>
+            <p:ph type="sldNum" sz="quarter" idx="11"/>
+          </p:nvPr>
+        </p:nvSpPr>
+        <p:spPr/>
+        <p:txBody>
+          <a:bodyPr/>
+          <a:lstStyle/>
+          <a:p>
+            <a:fld id="{20B01981-BAC9-448B-9192-9C05FAA59408}" type="slidenum">
+              <a:rPr lang="en-US" noProof="0" smtClean="0"/>
+              <a:pPr/>
+              <a:t>3</a:t>
+            </a:fld>
+            <a:endParaRPr lang="en-US" noProof="0" dirty="0"/>
+          </a:p>
+        </p:txBody>
+      </p:sp>
+      <p:sp>
+        <p:nvSpPr>
+          <p:cNvPr id="7" name="Google Shape;129;p24">
+            <a:extLst>
+              <a:ext uri="{FF2B5EF4-FFF2-40B4-BE49-F238E27FC236}">
+                <a16:creationId xmlns:a16="http://schemas.microsoft.com/office/drawing/2014/main" id="{5C54AC6F-DC62-0DF5-45B1-DB8B8FEB25CA}"/>
+              </a:ext>
+            </a:extLst>
+          </p:cNvPr>
+          <p:cNvSpPr txBox="1">
+            <a:spLocks/>
+          </p:cNvSpPr>
+          <p:nvPr/>
+        </p:nvSpPr>
+        <p:spPr>
+          <a:xfrm>
+            <a:off x="450519" y="399459"/>
+            <a:ext cx="4157108" cy="643280"/>
+          </a:xfrm>
+          <a:prstGeom prst="rect">
+            <a:avLst/>
+          </a:prstGeom>
+          <a:noFill/>
+          <a:ln>
+            <a:noFill/>
+          </a:ln>
+        </p:spPr>
+        <p:txBody>
+          <a:bodyPr spcFirstLastPara="1" vert="horz" wrap="square" lIns="91433" tIns="45700" rIns="91433" bIns="45700" rtlCol="0" anchor="t" anchorCtr="0">
+            <a:normAutofit/>
+          </a:bodyPr>
+          <a:lstStyle>
+            <a:lvl1pPr marL="228600" indent="-228600" algn="l" defTabSz="914400" rtl="0" eaLnBrk="1" latinLnBrk="0" hangingPunct="1">
+              <a:lnSpc>
+                <a:spcPct val="90000"/>
+              </a:lnSpc>
+              <a:spcBef>
+                <a:spcPts val="1000"/>
+              </a:spcBef>
+              <a:buFont typeface="Arial" panose="020B0604020202020204" pitchFamily="34" charset="0"/>
+              <a:buChar char="•"/>
+              <a:defRPr sz="2800" kern="1200">
+                <a:solidFill>
+                  <a:schemeClr val="tx1"/>
+                </a:solidFill>
+                <a:latin typeface="+mn-lt"/>
+                <a:ea typeface="+mn-ea"/>
+                <a:cs typeface="+mn-cs"/>
+              </a:defRPr>
+            </a:lvl1pPr>
+            <a:lvl2pPr marL="685800" indent="-228600" algn="l" defTabSz="914400" rtl="0" eaLnBrk="1" latinLnBrk="0" hangingPunct="1">
+              <a:lnSpc>
+                <a:spcPct val="90000"/>
+              </a:lnSpc>
+              <a:spcBef>
+                <a:spcPts val="500"/>
+              </a:spcBef>
+              <a:buFont typeface="Arial" panose="020B0604020202020204" pitchFamily="34" charset="0"/>
+              <a:buChar char="•"/>
+              <a:defRPr sz="2400" kern="1200">
+                <a:solidFill>
+                  <a:schemeClr val="tx1"/>
+                </a:solidFill>
+                <a:latin typeface="+mn-lt"/>
+                <a:ea typeface="+mn-ea"/>
+                <a:cs typeface="+mn-cs"/>
+              </a:defRPr>
+            </a:lvl2pPr>
+            <a:lvl3pPr marL="1143000" indent="-228600" algn="l" defTabSz="914400" rtl="0" eaLnBrk="1" latinLnBrk="0" hangingPunct="1">
+              <a:lnSpc>
+                <a:spcPct val="90000"/>
+              </a:lnSpc>
+              <a:spcBef>
+                <a:spcPts val="500"/>
+              </a:spcBef>
+              <a:buFont typeface="Arial" panose="020B0604020202020204" pitchFamily="34" charset="0"/>
+              <a:buChar char="•"/>
+              <a:defRPr sz="2000" kern="1200">
+                <a:solidFill>
+                  <a:schemeClr val="tx1"/>
+                </a:solidFill>
+                <a:latin typeface="+mn-lt"/>
+                <a:ea typeface="+mn-ea"/>
+                <a:cs typeface="+mn-cs"/>
+              </a:defRPr>
+            </a:lvl3pPr>
+            <a:lvl4pPr marL="1600200" indent="-228600" algn="l" defTabSz="914400" rtl="0" eaLnBrk="1" latinLnBrk="0" hangingPunct="1">
+              <a:lnSpc>
+                <a:spcPct val="90000"/>
+              </a:lnSpc>
+              <a:spcBef>
+                <a:spcPts val="500"/>
+              </a:spcBef>
+              <a:buFont typeface="Arial" panose="020B0604020202020204" pitchFamily="34" charset="0"/>
+              <a:buChar char="•"/>
+              <a:defRPr sz="1800" kern="1200">
+                <a:solidFill>
+                  <a:schemeClr val="tx1"/>
+                </a:solidFill>
+                <a:latin typeface="+mn-lt"/>
+                <a:ea typeface="+mn-ea"/>
+                <a:cs typeface="+mn-cs"/>
+              </a:defRPr>
+            </a:lvl4pPr>
+            <a:lvl5pPr marL="2057400" indent="-228600" algn="l" defTabSz="914400" rtl="0" eaLnBrk="1" latinLnBrk="0" hangingPunct="1">
+              <a:lnSpc>
+                <a:spcPct val="90000"/>
+              </a:lnSpc>
+              <a:spcBef>
+                <a:spcPts val="500"/>
+              </a:spcBef>
+              <a:buFont typeface="Arial" panose="020B0604020202020204" pitchFamily="34" charset="0"/>
+              <a:buChar char="•"/>
+              <a:defRPr sz="1800" kern="1200">
+                <a:solidFill>
+                  <a:schemeClr val="tx1"/>
+                </a:solidFill>
+                <a:latin typeface="+mn-lt"/>
+                <a:ea typeface="+mn-ea"/>
+                <a:cs typeface="+mn-cs"/>
+              </a:defRPr>
+            </a:lvl5pPr>
+            <a:lvl6pPr marL="2514600" indent="-228600" algn="l" defTabSz="914400" rtl="0" eaLnBrk="1" latinLnBrk="0" hangingPunct="1">
+              <a:lnSpc>
+                <a:spcPct val="90000"/>
+              </a:lnSpc>
+              <a:spcBef>
+                <a:spcPts val="500"/>
+              </a:spcBef>
+              <a:buFont typeface="Arial" panose="020B0604020202020204" pitchFamily="34" charset="0"/>
+              <a:buChar char="•"/>
+              <a:defRPr sz="1800" kern="1200">
+                <a:solidFill>
+                  <a:schemeClr val="tx1"/>
+                </a:solidFill>
+                <a:latin typeface="+mn-lt"/>
+                <a:ea typeface="+mn-ea"/>
+                <a:cs typeface="+mn-cs"/>
+              </a:defRPr>
+            </a:lvl6pPr>
+            <a:lvl7pPr marL="2971800" indent="-228600" algn="l" defTabSz="914400" rtl="0" eaLnBrk="1" latinLnBrk="0" hangingPunct="1">
+              <a:lnSpc>
+                <a:spcPct val="90000"/>
+              </a:lnSpc>
+              <a:spcBef>
+                <a:spcPts val="500"/>
+              </a:spcBef>
+              <a:buFont typeface="Arial" panose="020B0604020202020204" pitchFamily="34" charset="0"/>
+              <a:buChar char="•"/>
+              <a:defRPr sz="1800" kern="1200">
+                <a:solidFill>
+                  <a:schemeClr val="tx1"/>
+                </a:solidFill>
+                <a:latin typeface="+mn-lt"/>
+                <a:ea typeface="+mn-ea"/>
+                <a:cs typeface="+mn-cs"/>
+              </a:defRPr>
+            </a:lvl7pPr>
+            <a:lvl8pPr marL="3429000" indent="-228600" algn="l" defTabSz="914400" rtl="0" eaLnBrk="1" latinLnBrk="0" hangingPunct="1">
+              <a:lnSpc>
+                <a:spcPct val="90000"/>
+              </a:lnSpc>
+              <a:spcBef>
+                <a:spcPts val="500"/>
+              </a:spcBef>
+              <a:buFont typeface="Arial" panose="020B0604020202020204" pitchFamily="34" charset="0"/>
+              <a:buChar char="•"/>
+              <a:defRPr sz="1800" kern="1200">
+                <a:solidFill>
+                  <a:schemeClr val="tx1"/>
+                </a:solidFill>
+                <a:latin typeface="+mn-lt"/>
+                <a:ea typeface="+mn-ea"/>
+                <a:cs typeface="+mn-cs"/>
+              </a:defRPr>
+            </a:lvl8pPr>
+            <a:lvl9pPr marL="3886200" indent="-228600" algn="l" defTabSz="914400" rtl="0" eaLnBrk="1" latinLnBrk="0" hangingPunct="1">
+              <a:lnSpc>
+                <a:spcPct val="90000"/>
+              </a:lnSpc>
+              <a:spcBef>
+                <a:spcPts val="500"/>
+              </a:spcBef>
+              <a:buFont typeface="Arial" panose="020B0604020202020204" pitchFamily="34" charset="0"/>
+              <a:buChar char="•"/>
+              <a:defRPr sz="1800" kern="1200">
+                <a:solidFill>
+                  <a:schemeClr val="tx1"/>
+                </a:solidFill>
+                <a:latin typeface="+mn-lt"/>
+                <a:ea typeface="+mn-ea"/>
+                <a:cs typeface="+mn-cs"/>
+              </a:defRPr>
+            </a:lvl9pPr>
+          </a:lstStyle>
+          <a:p>
+            <a:pPr marL="0" marR="0" lvl="0" indent="0" algn="l" defTabSz="914400" rtl="0" eaLnBrk="1" fontAlgn="auto" latinLnBrk="0" hangingPunct="1">
+              <a:lnSpc>
+                <a:spcPct val="90000"/>
+              </a:lnSpc>
+              <a:spcBef>
+                <a:spcPts val="0"/>
+              </a:spcBef>
+              <a:spcAft>
+                <a:spcPts val="0"/>
+              </a:spcAft>
+              <a:buClr>
+                <a:srgbClr val="00AAF0"/>
+              </a:buClr>
+              <a:buSzPts val="1800"/>
+              <a:buFont typeface="Arial" panose="020B0604020202020204" pitchFamily="34" charset="0"/>
+              <a:buNone/>
+              <a:tabLst/>
+              <a:defRPr/>
+            </a:pPr>
+            <a:r>
+              <a:rPr kumimoji="0" lang="en-US" sz="2400" b="1" i="0" u="none" strike="noStrike" kern="1200" cap="none" spc="0" normalizeH="0" baseline="0" noProof="0" dirty="0">
+                <a:ln>
+                  <a:noFill/>
+                </a:ln>
+                <a:solidFill>
+                  <a:srgbClr val="00AAF0"/>
+                </a:solidFill>
+                <a:effectLst/>
+                <a:uLnTx/>
+                <a:uFillTx/>
+                <a:latin typeface="Verdana"/>
+                <a:ea typeface="Verdana"/>
+                <a:sym typeface="Verdana"/>
+              </a:rPr>
+              <a:t>Question and Answers</a:t>
+            </a:r>
+          </a:p>
+          <a:p>
+            <a:pPr marL="0" indent="0">
+              <a:spcBef>
+                <a:spcPts val="0"/>
+              </a:spcBef>
+              <a:buNone/>
+            </a:pPr>
+            <a:endParaRPr lang="en-US" dirty="0"/>
+          </a:p>
+        </p:txBody>
+      </p:sp>
+      <p:sp>
+        <p:nvSpPr>
+          <p:cNvPr id="2" name="AutoShape 2" descr="preview url image">
+            <a:extLst>
+              <a:ext uri="{FF2B5EF4-FFF2-40B4-BE49-F238E27FC236}">
+                <a16:creationId xmlns:a16="http://schemas.microsoft.com/office/drawing/2014/main" id="{EE3D2BFD-6028-0672-0008-7C3D05E2C9CD}"/>
+              </a:ext>
+            </a:extLst>
+          </p:cNvPr>
+          <p:cNvSpPr>
+            <a:spLocks noChangeAspect="1" noChangeArrowheads="1"/>
+          </p:cNvSpPr>
+          <p:nvPr/>
+        </p:nvSpPr>
+        <p:spPr bwMode="auto">
+          <a:xfrm>
+            <a:off x="5943600" y="3276600"/>
+            <a:ext cx="304800" cy="304800"/>
+          </a:xfrm>
+          <a:prstGeom prst="rect">
+            <a:avLst/>
+          </a:prstGeom>
+          <a:noFill/>
+          <a:extLst>
+            <a:ext uri="{909E8E84-426E-40DD-AFC4-6F175D3DCCD1}">
+              <a14:hiddenFill xmlns:a14="http://schemas.microsoft.com/office/drawing/2010/main">
+                <a:solidFill>
+                  <a:srgbClr val="FFFFFF"/>
+                </a:solidFill>
+              </a14:hiddenFill>
+            </a:ext>
+          </a:extLst>
+        </p:spPr>
+        <p:txBody>
+          <a:bodyPr vert="horz" wrap="square" lIns="91440" tIns="45720" rIns="91440" bIns="45720" numCol="1" anchor="t" anchorCtr="0" compatLnSpc="1">
+            <a:prstTxWarp prst="textNoShape">
+              <a:avLst/>
+            </a:prstTxWarp>
+          </a:bodyPr>
+          <a:lstStyle/>
+          <a:p>
+            <a:endParaRPr lang="pt-PT"/>
+          </a:p>
+        </p:txBody>
+      </p:sp>
+      <p:pic>
+        <p:nvPicPr>
+          <p:cNvPr id="3" name="Picture 4" descr="Overview of the experimental steps in a RNAseq protocol. The cDNA... |  Download Scientific Diagram">
+            <a:extLst>
+              <a:ext uri="{FF2B5EF4-FFF2-40B4-BE49-F238E27FC236}">
+                <a16:creationId xmlns:a16="http://schemas.microsoft.com/office/drawing/2014/main" id="{2C8D00C0-8EFC-CFED-599A-C3F9E93AA66B}"/>
+              </a:ext>
+            </a:extLst>
+          </p:cNvPr>
+          <p:cNvPicPr>
+            <a:picLocks noChangeAspect="1" noChangeArrowheads="1"/>
+          </p:cNvPicPr>
+          <p:nvPr/>
+        </p:nvPicPr>
+        <p:blipFill>
+          <a:blip r:embed="rId2">
+            <a:extLst>
+              <a:ext uri="{28A0092B-C50C-407E-A947-70E740481C1C}">
+                <a14:useLocalDpi xmlns:a14="http://schemas.microsoft.com/office/drawing/2010/main" val="0"/>
+              </a:ext>
+            </a:extLst>
+          </a:blip>
+          <a:srcRect/>
+          <a:stretch>
+            <a:fillRect/>
+          </a:stretch>
+        </p:blipFill>
+        <p:spPr bwMode="auto">
+          <a:xfrm>
+            <a:off x="487934" y="2032590"/>
+            <a:ext cx="6188912" cy="2970678"/>
+          </a:xfrm>
+          <a:prstGeom prst="rect">
+            <a:avLst/>
+          </a:prstGeom>
+          <a:noFill/>
+          <a:extLst>
+            <a:ext uri="{909E8E84-426E-40DD-AFC4-6F175D3DCCD1}">
+              <a14:hiddenFill xmlns:a14="http://schemas.microsoft.com/office/drawing/2010/main">
+                <a:solidFill>
+                  <a:srgbClr val="FFFFFF"/>
+                </a:solidFill>
+              </a14:hiddenFill>
+            </a:ext>
+          </a:extLst>
+        </p:spPr>
+      </p:pic>
+      <p:sp>
+        <p:nvSpPr>
+          <p:cNvPr id="6" name="Rectangle 16">
+            <a:extLst>
+              <a:ext uri="{FF2B5EF4-FFF2-40B4-BE49-F238E27FC236}">
+                <a16:creationId xmlns:a16="http://schemas.microsoft.com/office/drawing/2014/main" id="{A307C9F4-71AB-87D8-8E52-0355BE0A838A}"/>
+              </a:ext>
+            </a:extLst>
+          </p:cNvPr>
+          <p:cNvSpPr/>
+          <p:nvPr/>
+        </p:nvSpPr>
+        <p:spPr>
+          <a:xfrm>
+            <a:off x="487933" y="3487257"/>
+            <a:ext cx="3678625" cy="1516011"/>
+          </a:xfrm>
+          <a:prstGeom prst="rect">
+            <a:avLst/>
+          </a:prstGeom>
+          <a:noFill/>
+          <a:ln w="38100">
+            <a:solidFill>
+              <a:srgbClr val="12A0CB"/>
+            </a:solidFill>
+          </a:ln>
+        </p:spPr>
+        <p:style>
+          <a:lnRef idx="2">
+            <a:schemeClr val="accent1">
+              <a:shade val="15000"/>
+            </a:schemeClr>
+          </a:lnRef>
+          <a:fillRef idx="1">
+            <a:schemeClr val="accent1"/>
+          </a:fillRef>
+          <a:effectRef idx="0">
+            <a:schemeClr val="accent1"/>
+          </a:effectRef>
+          <a:fontRef idx="minor">
+            <a:schemeClr val="lt1"/>
+          </a:fontRef>
+        </p:style>
+        <p:txBody>
+          <a:bodyPr rtlCol="0" anchor="ctr"/>
+          <a:lstStyle/>
+          <a:p>
+            <a:pPr algn="ctr"/>
+            <a:endParaRPr lang="en-GB"/>
+          </a:p>
+        </p:txBody>
+      </p:sp>
+      <p:sp>
+        <p:nvSpPr>
+          <p:cNvPr id="11" name="Arrow: Bent 5">
+            <a:extLst>
+              <a:ext uri="{FF2B5EF4-FFF2-40B4-BE49-F238E27FC236}">
+                <a16:creationId xmlns:a16="http://schemas.microsoft.com/office/drawing/2014/main" id="{4A2FA27C-9AA9-29E7-207E-2BAE672D7A6A}"/>
+              </a:ext>
+            </a:extLst>
+          </p:cNvPr>
+          <p:cNvSpPr/>
+          <p:nvPr/>
+        </p:nvSpPr>
+        <p:spPr>
+          <a:xfrm flipV="1">
+            <a:off x="1000663" y="4477108"/>
+            <a:ext cx="6909759" cy="1500995"/>
+          </a:xfrm>
+          <a:prstGeom prst="bentArrow">
+            <a:avLst>
+              <a:gd name="adj1" fmla="val 6476"/>
+              <a:gd name="adj2" fmla="val 10803"/>
+              <a:gd name="adj3" fmla="val 25000"/>
+              <a:gd name="adj4" fmla="val 43750"/>
+            </a:avLst>
+          </a:prstGeom>
+        </p:spPr>
+        <p:style>
+          <a:lnRef idx="2">
+            <a:schemeClr val="accent1">
+              <a:shade val="15000"/>
+            </a:schemeClr>
+          </a:lnRef>
+          <a:fillRef idx="1">
+            <a:schemeClr val="accent1"/>
+          </a:fillRef>
+          <a:effectRef idx="0">
+            <a:schemeClr val="accent1"/>
+          </a:effectRef>
+          <a:fontRef idx="minor">
+            <a:schemeClr val="lt1"/>
+          </a:fontRef>
+        </p:style>
+        <p:txBody>
+          <a:bodyPr rtlCol="0" anchor="ctr"/>
+          <a:lstStyle/>
+          <a:p>
+            <a:pPr algn="ctr"/>
+            <a:endParaRPr lang="en-GB">
+              <a:solidFill>
+                <a:schemeClr val="tx1"/>
+              </a:solidFill>
+            </a:endParaRPr>
+          </a:p>
+        </p:txBody>
+      </p:sp>
+      <p:sp>
+        <p:nvSpPr>
+          <p:cNvPr id="13" name="TextBox 17">
+            <a:extLst>
+              <a:ext uri="{FF2B5EF4-FFF2-40B4-BE49-F238E27FC236}">
+                <a16:creationId xmlns:a16="http://schemas.microsoft.com/office/drawing/2014/main" id="{18FD6773-176E-EF17-FC19-6FFF29E5D851}"/>
+              </a:ext>
+            </a:extLst>
+          </p:cNvPr>
+          <p:cNvSpPr txBox="1"/>
+          <p:nvPr/>
+        </p:nvSpPr>
+        <p:spPr>
+          <a:xfrm>
+            <a:off x="1226941" y="5002970"/>
+            <a:ext cx="2857064" cy="369332"/>
+          </a:xfrm>
+          <a:prstGeom prst="rect">
+            <a:avLst/>
+          </a:prstGeom>
+          <a:noFill/>
+        </p:spPr>
+        <p:txBody>
+          <a:bodyPr wrap="none" rtlCol="0">
+            <a:spAutoFit/>
+          </a:bodyPr>
+          <a:lstStyle/>
+          <a:p>
+            <a:r>
+              <a:rPr lang="en-GB" b="1" dirty="0"/>
+              <a:t>Bioinformatics data analysis</a:t>
+            </a:r>
+          </a:p>
+        </p:txBody>
+      </p:sp>
+      <p:pic>
+        <p:nvPicPr>
+          <p:cNvPr id="15" name="Imagem 14">
+            <a:extLst>
+              <a:ext uri="{FF2B5EF4-FFF2-40B4-BE49-F238E27FC236}">
+                <a16:creationId xmlns:a16="http://schemas.microsoft.com/office/drawing/2014/main" id="{B18E4D6C-1910-BA14-E589-273DFE6B3F69}"/>
+              </a:ext>
+            </a:extLst>
+          </p:cNvPr>
+          <p:cNvPicPr>
+            <a:picLocks noChangeAspect="1"/>
+          </p:cNvPicPr>
+          <p:nvPr/>
+        </p:nvPicPr>
+        <p:blipFill>
+          <a:blip r:embed="rId3">
+            <a:extLst>
+              <a:ext uri="{28A0092B-C50C-407E-A947-70E740481C1C}">
+                <a14:useLocalDpi xmlns:a14="http://schemas.microsoft.com/office/drawing/2010/main" val="0"/>
+              </a:ext>
+            </a:extLst>
+          </a:blip>
+          <a:stretch>
+            <a:fillRect/>
+          </a:stretch>
+        </p:blipFill>
+        <p:spPr>
+          <a:xfrm>
+            <a:off x="8025442" y="2658506"/>
+            <a:ext cx="3898335" cy="3637203"/>
+          </a:xfrm>
+          <a:prstGeom prst="rect">
+            <a:avLst/>
+          </a:prstGeom>
+        </p:spPr>
+      </p:pic>
+      <p:pic>
+        <p:nvPicPr>
+          <p:cNvPr id="17" name="Imagem 16">
+            <a:extLst>
+              <a:ext uri="{FF2B5EF4-FFF2-40B4-BE49-F238E27FC236}">
+                <a16:creationId xmlns:a16="http://schemas.microsoft.com/office/drawing/2014/main" id="{8FB05930-BEC4-18E6-D9B9-5AA1183F21BF}"/>
+              </a:ext>
+            </a:extLst>
+          </p:cNvPr>
+          <p:cNvPicPr>
+            <a:picLocks noChangeAspect="1"/>
+          </p:cNvPicPr>
+          <p:nvPr/>
+        </p:nvPicPr>
+        <p:blipFill>
+          <a:blip r:embed="rId4">
+            <a:extLst>
+              <a:ext uri="{28A0092B-C50C-407E-A947-70E740481C1C}">
+                <a14:useLocalDpi xmlns:a14="http://schemas.microsoft.com/office/drawing/2010/main" val="0"/>
+              </a:ext>
+            </a:extLst>
+          </a:blip>
+          <a:stretch>
+            <a:fillRect/>
+          </a:stretch>
+        </p:blipFill>
+        <p:spPr>
+          <a:xfrm>
+            <a:off x="8807638" y="18803"/>
+            <a:ext cx="3384362" cy="6858000"/>
+          </a:xfrm>
+          <a:prstGeom prst="rect">
+            <a:avLst/>
+          </a:prstGeom>
+        </p:spPr>
+      </p:pic>
+      <p:sp>
+        <p:nvSpPr>
+          <p:cNvPr id="19" name="AutoShape 2" descr="Pipeline">
+            <a:extLst>
+              <a:ext uri="{FF2B5EF4-FFF2-40B4-BE49-F238E27FC236}">
+                <a16:creationId xmlns:a16="http://schemas.microsoft.com/office/drawing/2014/main" id="{3A667708-984A-932C-ACA4-B9285891B415}"/>
+              </a:ext>
+            </a:extLst>
+          </p:cNvPr>
+          <p:cNvSpPr>
+            <a:spLocks noChangeAspect="1" noChangeArrowheads="1"/>
+          </p:cNvSpPr>
+          <p:nvPr/>
+        </p:nvSpPr>
+        <p:spPr bwMode="auto">
+          <a:xfrm>
+            <a:off x="6096000" y="3429000"/>
+            <a:ext cx="304800" cy="304800"/>
+          </a:xfrm>
+          <a:prstGeom prst="rect">
+            <a:avLst/>
+          </a:prstGeom>
+          <a:noFill/>
+          <a:extLst>
+            <a:ext uri="{909E8E84-426E-40DD-AFC4-6F175D3DCCD1}">
+              <a14:hiddenFill xmlns:a14="http://schemas.microsoft.com/office/drawing/2010/main">
+                <a:solidFill>
+                  <a:srgbClr val="FFFFFF"/>
+                </a:solidFill>
+              </a14:hiddenFill>
+            </a:ext>
+          </a:extLst>
+        </p:spPr>
+        <p:txBody>
+          <a:bodyPr vert="horz" wrap="square" lIns="91440" tIns="45720" rIns="91440" bIns="45720" numCol="1" anchor="t" anchorCtr="0" compatLnSpc="1">
+            <a:prstTxWarp prst="textNoShape">
+              <a:avLst/>
+            </a:prstTxWarp>
+          </a:bodyPr>
+          <a:lstStyle/>
+          <a:p>
+            <a:endParaRPr lang="pt-PT"/>
+          </a:p>
+        </p:txBody>
+      </p:sp>
+      <p:pic>
+        <p:nvPicPr>
+          <p:cNvPr id="21" name="Imagem 20">
+            <a:extLst>
+              <a:ext uri="{FF2B5EF4-FFF2-40B4-BE49-F238E27FC236}">
+                <a16:creationId xmlns:a16="http://schemas.microsoft.com/office/drawing/2014/main" id="{36535555-C817-471C-7854-10639254CB14}"/>
+              </a:ext>
+            </a:extLst>
+          </p:cNvPr>
+          <p:cNvPicPr>
+            <a:picLocks noChangeAspect="1"/>
+          </p:cNvPicPr>
+          <p:nvPr/>
+        </p:nvPicPr>
+        <p:blipFill>
+          <a:blip r:embed="rId5">
+            <a:extLst>
+              <a:ext uri="{28A0092B-C50C-407E-A947-70E740481C1C}">
+                <a14:useLocalDpi xmlns:a14="http://schemas.microsoft.com/office/drawing/2010/main" val="0"/>
+              </a:ext>
+            </a:extLst>
+          </a:blip>
+          <a:stretch>
+            <a:fillRect/>
+          </a:stretch>
+        </p:blipFill>
+        <p:spPr>
+          <a:xfrm>
+            <a:off x="487932" y="1042739"/>
+            <a:ext cx="5907153" cy="4960986"/>
+          </a:xfrm>
+          <a:prstGeom prst="rect">
+            <a:avLst/>
+          </a:prstGeom>
+        </p:spPr>
+      </p:pic>
+    </p:spTree>
+    <p:extLst>
+      <p:ext uri="{BB962C8B-B14F-4D97-AF65-F5344CB8AC3E}">
+        <p14:creationId xmlns:p14="http://schemas.microsoft.com/office/powerpoint/2010/main" val="1694088089"/>
+      </p:ext>
+    </p:extLst>
+  </p:cSld>
+  <p:clrMapOvr>
+    <a:masterClrMapping/>
+  </p:clrMapOvr>
+  <p:timing>
+    <p:tnLst>
+      <p:par>
+        <p:cTn id="1" dur="indefinite" restart="never" nodeType="tmRoot">
+          <p:childTnLst>
+            <p:seq concurrent="1" nextAc="seek">
+              <p:cTn id="2" dur="indefinite" nodeType="mainSeq">
+                <p:childTnLst>
+                  <p:par>
+                    <p:cTn id="3" fill="hold">
+                      <p:stCondLst>
+                        <p:cond delay="indefinite"/>
+                      </p:stCondLst>
+                      <p:childTnLst>
+                        <p:par>
+                          <p:cTn id="4" fill="hold">
+                            <p:stCondLst>
+                              <p:cond delay="0"/>
+                            </p:stCondLst>
+                            <p:childTnLst>
+                              <p:par>
+                                <p:cTn id="5" presetID="10" presetClass="entr" presetSubtype="0" fill="hold" grpId="0" nodeType="clickEffect">
+                                  <p:stCondLst>
+                                    <p:cond delay="0"/>
+                                  </p:stCondLst>
+                                  <p:childTnLst>
+                                    <p:set>
+                                      <p:cBhvr>
+                                        <p:cTn id="6" dur="1" fill="hold">
+                                          <p:stCondLst>
+                                            <p:cond delay="0"/>
+                                          </p:stCondLst>
+                                        </p:cTn>
+                                        <p:tgtEl>
+                                          <p:spTgt spid="6"/>
+                                        </p:tgtEl>
+                                        <p:attrNameLst>
+                                          <p:attrName>style.visibility</p:attrName>
+                                        </p:attrNameLst>
+                                      </p:cBhvr>
+                                      <p:to>
+                                        <p:strVal val="visible"/>
+                                      </p:to>
+                                    </p:set>
+                                    <p:animEffect transition="in" filter="fade">
+                                      <p:cBhvr>
+                                        <p:cTn id="7" dur="500"/>
+                                        <p:tgtEl>
+                                          <p:spTgt spid="6"/>
+                                        </p:tgtEl>
+                                      </p:cBhvr>
+                                    </p:animEffect>
+                                  </p:childTnLst>
+                                </p:cTn>
+                              </p:par>
+                              <p:par>
+                                <p:cTn id="8" presetID="10" presetClass="entr" presetSubtype="0" fill="hold" grpId="0" nodeType="withEffect">
+                                  <p:stCondLst>
+                                    <p:cond delay="0"/>
+                                  </p:stCondLst>
+                                  <p:childTnLst>
+                                    <p:set>
+                                      <p:cBhvr>
+                                        <p:cTn id="9" dur="1" fill="hold">
+                                          <p:stCondLst>
+                                            <p:cond delay="0"/>
+                                          </p:stCondLst>
+                                        </p:cTn>
+                                        <p:tgtEl>
+                                          <p:spTgt spid="13"/>
+                                        </p:tgtEl>
+                                        <p:attrNameLst>
+                                          <p:attrName>style.visibility</p:attrName>
+                                        </p:attrNameLst>
+                                      </p:cBhvr>
+                                      <p:to>
+                                        <p:strVal val="visible"/>
+                                      </p:to>
+                                    </p:set>
+                                    <p:animEffect transition="in" filter="fade">
+                                      <p:cBhvr>
+                                        <p:cTn id="10" dur="500"/>
+                                        <p:tgtEl>
+                                          <p:spTgt spid="13"/>
+                                        </p:tgtEl>
+                                      </p:cBhvr>
+                                    </p:animEffect>
+                                  </p:childTnLst>
+                                </p:cTn>
+                              </p:par>
+                            </p:childTnLst>
+                          </p:cTn>
+                        </p:par>
+                      </p:childTnLst>
+                    </p:cTn>
+                  </p:par>
+                  <p:par>
+                    <p:cTn id="11" fill="hold">
+                      <p:stCondLst>
+                        <p:cond delay="indefinite"/>
+                      </p:stCondLst>
+                      <p:childTnLst>
+                        <p:par>
+                          <p:cTn id="12" fill="hold">
+                            <p:stCondLst>
+                              <p:cond delay="0"/>
+                            </p:stCondLst>
+                            <p:childTnLst>
+                              <p:par>
+                                <p:cTn id="13" presetID="3" presetClass="entr" presetSubtype="10" fill="hold" nodeType="clickEffect">
+                                  <p:stCondLst>
+                                    <p:cond delay="0"/>
+                                  </p:stCondLst>
+                                  <p:childTnLst>
+                                    <p:set>
+                                      <p:cBhvr>
+                                        <p:cTn id="14" dur="1" fill="hold">
+                                          <p:stCondLst>
+                                            <p:cond delay="0"/>
+                                          </p:stCondLst>
+                                        </p:cTn>
+                                        <p:tgtEl>
+                                          <p:spTgt spid="21"/>
+                                        </p:tgtEl>
+                                        <p:attrNameLst>
+                                          <p:attrName>style.visibility</p:attrName>
+                                        </p:attrNameLst>
+                                      </p:cBhvr>
+                                      <p:to>
+                                        <p:strVal val="visible"/>
+                                      </p:to>
+                                    </p:set>
+                                    <p:animEffect transition="in" filter="blinds(horizontal)">
+                                      <p:cBhvr>
+                                        <p:cTn id="15" dur="500"/>
+                                        <p:tgtEl>
+                                          <p:spTgt spid="21"/>
+                                        </p:tgtEl>
+                                      </p:cBhvr>
+                                    </p:animEffect>
+                                  </p:childTnLst>
+                                </p:cTn>
+                              </p:par>
+                              <p:par>
+                                <p:cTn id="16" presetID="10" presetClass="entr" presetSubtype="0" fill="hold" grpId="0" nodeType="withEffect">
+                                  <p:stCondLst>
+                                    <p:cond delay="0"/>
+                                  </p:stCondLst>
+                                  <p:childTnLst>
+                                    <p:set>
+                                      <p:cBhvr>
+                                        <p:cTn id="17" dur="1" fill="hold">
+                                          <p:stCondLst>
+                                            <p:cond delay="0"/>
+                                          </p:stCondLst>
+                                        </p:cTn>
+                                        <p:tgtEl>
+                                          <p:spTgt spid="11"/>
+                                        </p:tgtEl>
+                                        <p:attrNameLst>
+                                          <p:attrName>style.visibility</p:attrName>
+                                        </p:attrNameLst>
+                                      </p:cBhvr>
+                                      <p:to>
+                                        <p:strVal val="visible"/>
+                                      </p:to>
+                                    </p:set>
+                                    <p:animEffect transition="in" filter="fade">
+                                      <p:cBhvr>
+                                        <p:cTn id="18" dur="500"/>
+                                        <p:tgtEl>
+                                          <p:spTgt spid="11"/>
+                                        </p:tgtEl>
+                                      </p:cBhvr>
+                                    </p:animEffect>
+                                  </p:childTnLst>
+                                </p:cTn>
+                              </p:par>
+                            </p:childTnLst>
+                          </p:cTn>
+                        </p:par>
+                      </p:childTnLst>
+                    </p:cTn>
+                  </p:par>
+                  <p:par>
+                    <p:cTn id="19" fill="hold">
+                      <p:stCondLst>
+                        <p:cond delay="indefinite"/>
+                      </p:stCondLst>
+                      <p:childTnLst>
+                        <p:par>
+                          <p:cTn id="20" fill="hold">
+                            <p:stCondLst>
+                              <p:cond delay="0"/>
+                            </p:stCondLst>
+                            <p:childTnLst>
+                              <p:par>
+                                <p:cTn id="21" presetID="14" presetClass="entr" presetSubtype="10" fill="hold" nodeType="clickEffect">
+                                  <p:stCondLst>
+                                    <p:cond delay="0"/>
+                                  </p:stCondLst>
+                                  <p:childTnLst>
+                                    <p:set>
+                                      <p:cBhvr>
+                                        <p:cTn id="22" dur="1" fill="hold">
+                                          <p:stCondLst>
+                                            <p:cond delay="0"/>
+                                          </p:stCondLst>
+                                        </p:cTn>
+                                        <p:tgtEl>
+                                          <p:spTgt spid="17"/>
+                                        </p:tgtEl>
+                                        <p:attrNameLst>
+                                          <p:attrName>style.visibility</p:attrName>
+                                        </p:attrNameLst>
+                                      </p:cBhvr>
+                                      <p:to>
+                                        <p:strVal val="visible"/>
+                                      </p:to>
+                                    </p:set>
+                                    <p:animEffect transition="in" filter="randombar(horizontal)">
+                                      <p:cBhvr>
+                                        <p:cTn id="23" dur="500"/>
+                                        <p:tgtEl>
+                                          <p:spTgt spid="17"/>
+                                        </p:tgtEl>
+                                      </p:cBhvr>
+                                    </p:animEffect>
+                                  </p:childTnLst>
+                                </p:cTn>
+                              </p:par>
+                            </p:childTnLst>
+                          </p:cTn>
+                        </p:par>
+                      </p:childTnLst>
+                    </p:cTn>
+                  </p:par>
+                  <p:par>
+                    <p:cTn id="24" fill="hold">
+                      <p:stCondLst>
+                        <p:cond delay="indefinite"/>
+                      </p:stCondLst>
+                      <p:childTnLst>
+                        <p:par>
+                          <p:cTn id="25" fill="hold">
+                            <p:stCondLst>
+                              <p:cond delay="0"/>
+                            </p:stCondLst>
+                            <p:childTnLst>
+                              <p:par>
+                                <p:cTn id="26" presetID="3" presetClass="exit" presetSubtype="10" fill="hold" nodeType="clickEffect">
+                                  <p:stCondLst>
+                                    <p:cond delay="0"/>
+                                  </p:stCondLst>
+                                  <p:childTnLst>
+                                    <p:animEffect transition="out" filter="blinds(horizontal)">
+                                      <p:cBhvr>
+                                        <p:cTn id="27" dur="500"/>
+                                        <p:tgtEl>
+                                          <p:spTgt spid="17"/>
+                                        </p:tgtEl>
+                                      </p:cBhvr>
+                                    </p:animEffect>
+                                    <p:set>
+                                      <p:cBhvr>
+                                        <p:cTn id="28" dur="1" fill="hold">
+                                          <p:stCondLst>
+                                            <p:cond delay="499"/>
+                                          </p:stCondLst>
+                                        </p:cTn>
+                                        <p:tgtEl>
+                                          <p:spTgt spid="17"/>
+                                        </p:tgtEl>
+                                        <p:attrNameLst>
+                                          <p:attrName>style.visibility</p:attrName>
+                                        </p:attrNameLst>
+                                      </p:cBhvr>
+                                      <p:to>
+                                        <p:strVal val="hidden"/>
+                                      </p:to>
+                                    </p:set>
+                                  </p:childTnLst>
+                                </p:cTn>
+                              </p:par>
+                              <p:par>
+                                <p:cTn id="29" presetID="3" presetClass="entr" presetSubtype="10" fill="hold" nodeType="withEffect">
+                                  <p:stCondLst>
+                                    <p:cond delay="0"/>
+                                  </p:stCondLst>
+                                  <p:childTnLst>
+                                    <p:set>
+                                      <p:cBhvr>
+                                        <p:cTn id="30" dur="1" fill="hold">
+                                          <p:stCondLst>
+                                            <p:cond delay="0"/>
+                                          </p:stCondLst>
+                                        </p:cTn>
+                                        <p:tgtEl>
+                                          <p:spTgt spid="15"/>
+                                        </p:tgtEl>
+                                        <p:attrNameLst>
+                                          <p:attrName>style.visibility</p:attrName>
+                                        </p:attrNameLst>
+                                      </p:cBhvr>
+                                      <p:to>
+                                        <p:strVal val="visible"/>
+                                      </p:to>
+                                    </p:set>
+                                    <p:animEffect transition="in" filter="blinds(horizontal)">
+                                      <p:cBhvr>
+                                        <p:cTn id="31" dur="500"/>
+                                        <p:tgtEl>
+                                          <p:spTgt spid="15"/>
+                                        </p:tgtEl>
+                                      </p:cBhvr>
+                                    </p:animEffect>
+                                  </p:childTnLst>
+                                </p:cTn>
+                              </p:par>
+                            </p:childTnLst>
+                          </p:cTn>
+                        </p:par>
+                      </p:childTnLst>
+                    </p:cTn>
+                  </p:par>
+                </p:childTnLst>
+              </p:cTn>
+              <p:prevCondLst>
+                <p:cond evt="onPrev" delay="0">
+                  <p:tgtEl>
+                    <p:sldTgt/>
+                  </p:tgtEl>
+                </p:cond>
+              </p:prevCondLst>
+              <p:nextCondLst>
+                <p:cond evt="onNext" delay="0">
+                  <p:tgtEl>
+                    <p:sldTgt/>
+                  </p:tgtEl>
+                </p:cond>
+              </p:nextCondLst>
+            </p:seq>
+          </p:childTnLst>
+        </p:cTn>
+      </p:par>
+    </p:tnLst>
+    <p:bldLst>
+      <p:bldP spid="6" grpId="0" animBg="1"/>
+      <p:bldP spid="11" grpId="0" animBg="1"/>
+      <p:bldP spid="13" grpId="0"/>
+    </p:bldLst>
+  </p:timing>
+</p:sld>
+</file>
+
+<file path=ppt/slides/slide4.xml><?xml version="1.0" encoding="utf-8"?>
+<p:sld xmlns:a="http://schemas.openxmlformats.org/drawingml/2006/main" xmlns:r="http://schemas.openxmlformats.org/officeDocument/2006/relationships" xmlns:p="http://schemas.openxmlformats.org/presentationml/2006/main">
+  <p:cSld>
+    <p:spTree>
+      <p:nvGrpSpPr>
+        <p:cNvPr id="1" name="">
+          <a:extLst>
+            <a:ext uri="{FF2B5EF4-FFF2-40B4-BE49-F238E27FC236}">
               <a16:creationId xmlns:a16="http://schemas.microsoft.com/office/drawing/2014/main" id="{5A2B4C5C-D340-5529-2845-4D4234B78AC0}"/>
             </a:ext>
           </a:extLst>
@@ -5147,7 +6197,7 @@
             <a:fld id="{20B01981-BAC9-448B-9192-9C05FAA59408}" type="slidenum">
               <a:rPr lang="en-US" noProof="0" smtClean="0"/>
               <a:pPr/>
-              <a:t>3</a:t>
+              <a:t>4</a:t>
             </a:fld>
             <a:endParaRPr lang="en-US" noProof="0" dirty="0"/>
           </a:p>
@@ -6638,7 +7688,7 @@
 </p:sld>
 </file>
 
-<file path=ppt/slides/slide4.xml><?xml version="1.0" encoding="utf-8"?>
+<file path=ppt/slides/slide5.xml><?xml version="1.0" encoding="utf-8"?>
 <p:sld xmlns:a="http://schemas.openxmlformats.org/drawingml/2006/main" xmlns:r="http://schemas.openxmlformats.org/officeDocument/2006/relationships" xmlns:p="http://schemas.openxmlformats.org/presentationml/2006/main">
   <p:cSld>
     <p:spTree>
@@ -6784,7 +7834,7 @@
                 <a:latin typeface="+mj-lt"/>
               </a:rPr>
               <a:pPr/>
-              <a:t>4</a:t>
+              <a:t>5</a:t>
             </a:fld>
             <a:endParaRPr lang="en-US" sz="1200" b="1" noProof="0" dirty="0">
               <a:solidFill>

</xml_diff>